<commit_message>
Ajusta el texto de los cuadros de las diapositivas de KPI
En las diapositivas 3 a 6, los cuadros «Valor actual» y «Acción» pasan a
un registro más profesional: «Plan de acción», «Campaña asociada»,
variación en puntos porcentuales (p.p.) y descripciones de campaña
redactadas como medidas concretas. Se reparte el espacio interior del
cuadro «Valor actual» para que la línea de campaña no quede pegada al
borde, y las descripciones de campaña caben en dos líneas.

También se eliminan los <a:pPr> repetidos detrás de los runs, que hacían
el XML no válido y podían provocar el aviso de «reparar» en PowerPoint.

Co-Authored-By: Claude Opus 5.5 <noreply@anthropic.com>
Claude-Session: https://claude.ai/code/session_01XmwYQ8dbpQyCQc9EsMGuHB
</commit_message>
<xml_diff>
--- a/presentacion/Plantilla_KPIs_Seguridad_Obramat_Castellon.pptx
+++ b/presentacion/Plantilla_KPIs_Seguridad_Obramat_Castellon.pptx
@@ -4092,9 +4092,6 @@
               </a:rPr>
               <a:t>Mensaje principal: </a:t>
             </a:r>
-            <a:pPr indent="0" marL="0">
-              <a:buNone/>
-            </a:pPr>
             <a:r>
               <a:rPr lang="en-US" sz="1500" dirty="0">
                 <a:solidFill>
@@ -5710,8 +5707,8 @@
         </p:nvSpPr>
         <p:spPr>
           <a:xfrm>
-            <a:off x="5440680" y="1490472"/>
-            <a:ext cx="3017520" cy="548640"/>
+            <a:off x="5440680" y="1481328"/>
+            <a:ext cx="3017520" cy="457200"/>
           </a:xfrm>
           <a:prstGeom prst="rect">
             <a:avLst/>
@@ -5727,7 +5724,7 @@
               <a:buNone/>
             </a:pPr>
             <a:r>
-              <a:rPr lang="en-US" sz="3600" b="1" dirty="0">
+              <a:rPr lang="en-US" sz="3200" b="1" dirty="0">
                 <a:solidFill>
                   <a:schemeClr val="accent1"/>
                 </a:solidFill>
@@ -5746,8 +5743,8 @@
         </p:nvSpPr>
         <p:spPr>
           <a:xfrm>
-            <a:off x="5440680" y="2057400"/>
-            <a:ext cx="3017520" cy="274320"/>
+            <a:off x="5440680" y="1965960"/>
+            <a:ext cx="3017520" cy="256032"/>
           </a:xfrm>
           <a:prstGeom prst="rect">
             <a:avLst/>
@@ -5759,51 +5756,42 @@
           <a:bodyPr wrap="square" lIns="0" tIns="0" rIns="0" bIns="0" rtlCol="0" anchor="ctr"/>
           <a:lstStyle/>
           <a:p>
-            <a:pPr indent="0" marL="0">
-              <a:buNone/>
-            </a:pPr>
-            <a:r>
-              <a:rPr lang="en-US" sz="1200" b="1" dirty="0">
+            <a:pPr marL="0" indent="0">
+              <a:buNone/>
+            </a:pPr>
+            <a:r>
+              <a:rPr lang="es-ES" sz="1200" b="1" dirty="0">
                 <a:solidFill>
                   <a:schemeClr val="tx1"/>
                 </a:solidFill>
               </a:rPr>
               <a:t>Meta: </a:t>
             </a:r>
-            <a:pPr indent="0" marL="0">
-              <a:buNone/>
-            </a:pPr>
-            <a:r>
-              <a:rPr lang="en-US" sz="1200" dirty="0">
+            <a:r>
+              <a:rPr lang="es-ES" sz="1200" b="0" dirty="0">
                 <a:solidFill>
                   <a:schemeClr val="tx1"/>
                 </a:solidFill>
               </a:rPr>
-              <a:t>[00%]     </a:t>
-            </a:r>
-            <a:pPr indent="0" marL="0">
-              <a:buNone/>
-            </a:pPr>
-            <a:r>
-              <a:rPr lang="en-US" sz="1200" b="1" dirty="0">
+              <a:t>[00%]</a:t>
+            </a:r>
+            <a:r>
+              <a:rPr lang="es-ES" sz="1200" b="1" dirty="0">
                 <a:solidFill>
                   <a:schemeClr val="tx1"/>
                 </a:solidFill>
               </a:rPr>
-              <a:t>Variación: </a:t>
-            </a:r>
-            <a:pPr indent="0" marL="0">
-              <a:buNone/>
-            </a:pPr>
-            <a:r>
-              <a:rPr lang="en-US" sz="1200" dirty="0">
+              <a:t>     Variación: </a:t>
+            </a:r>
+            <a:r>
+              <a:rPr lang="es-ES" sz="1200" b="0" dirty="0">
                 <a:solidFill>
                   <a:schemeClr val="tx1"/>
                 </a:solidFill>
               </a:rPr>
-              <a:t>[±0 pts]</a:t>
-            </a:r>
-            <a:endParaRPr lang="en-US" sz="1200" dirty="0"/>
+              <a:t>[±0 p.p.]</a:t>
+            </a:r>
+            <a:endParaRPr lang="es-ES" sz="1200" dirty="0"/>
           </a:p>
         </p:txBody>
       </p:sp>
@@ -5815,8 +5803,8 @@
         </p:nvSpPr>
         <p:spPr>
           <a:xfrm>
-            <a:off x="5440680" y="2354580"/>
-            <a:ext cx="3017520" cy="205740"/>
+            <a:off x="5440680" y="2240280"/>
+            <a:ext cx="3017520" cy="256032"/>
           </a:xfrm>
           <a:prstGeom prst="rect">
             <a:avLst/>
@@ -5827,26 +5815,26 @@
           <a:bodyPr wrap="square" lIns="0" tIns="0" rIns="0" bIns="0" rtlCol="0" anchor="ctr"/>
           <a:lstStyle/>
           <a:p>
-            <a:pPr indent="0" marL="0">
-              <a:buNone/>
-            </a:pPr>
-            <a:r>
-              <a:rPr lang="es-ES" sz="1200" b="1" dirty="0">
+            <a:pPr marL="0" indent="0">
+              <a:buNone/>
+            </a:pPr>
+            <a:r>
+              <a:rPr lang="es-ES" sz="1100" b="1" dirty="0">
                 <a:solidFill>
                   <a:schemeClr val="tx1"/>
                 </a:solidFill>
               </a:rPr>
-              <a:t>Campaña: </a:t>
-            </a:r>
-            <a:r>
-              <a:rPr lang="es-ES" sz="1200" b="1" dirty="0">
+              <a:t>Campaña asociada: </a:t>
+            </a:r>
+            <a:r>
+              <a:rPr lang="es-ES" sz="1100" b="1" dirty="0">
                 <a:solidFill>
                   <a:schemeClr val="accent1"/>
                 </a:solidFill>
               </a:rPr>
               <a:t>«EPI siempre puesto»</a:t>
             </a:r>
-            <a:endParaRPr lang="es-ES" sz="1200" dirty="0"/>
+            <a:endParaRPr lang="es-ES" sz="1100" dirty="0"/>
           </a:p>
         </p:txBody>
       </p:sp>
@@ -5974,8 +5962,8 @@
         </p:nvSpPr>
         <p:spPr>
           <a:xfrm>
-            <a:off x="5394960" y="3630168"/>
-            <a:ext cx="3108960" cy="877824"/>
+            <a:off x="5394960" y="3639312"/>
+            <a:ext cx="3108960" cy="859536"/>
           </a:xfrm>
           <a:prstGeom prst="rect">
             <a:avLst/>
@@ -5987,39 +5975,36 @@
           <a:bodyPr wrap="square" lIns="0" tIns="0" rIns="0" bIns="0" rtlCol="0" anchor="ctr"/>
           <a:lstStyle/>
           <a:p>
-            <a:pPr indent="0" marL="0">
-              <a:buNone/>
-            </a:pPr>
-            <a:r>
-              <a:rPr lang="en-US" sz="1300" b="1" dirty="0">
+            <a:pPr marL="0" indent="0">
+              <a:buNone/>
+            </a:pPr>
+            <a:r>
+              <a:rPr lang="es-ES" sz="1200" b="1" dirty="0">
                 <a:solidFill>
                   <a:schemeClr val="bg1"/>
                 </a:solidFill>
               </a:rPr>
-              <a:t>Acción: </a:t>
-            </a:r>
-            <a:pPr indent="0" marL="0">
-              <a:buNone/>
-            </a:pPr>
-            <a:r>
-              <a:rPr lang="en-US" sz="1300" dirty="0">
+              <a:t>Plan de acción: </a:t>
+            </a:r>
+            <a:r>
+              <a:rPr lang="es-ES" sz="1200" b="0" dirty="0">
                 <a:solidFill>
                   <a:schemeClr val="bg1"/>
                 </a:solidFill>
               </a:rPr>
-              <a:t>[Qué haremos para mejorar o mantener el resultado]</a:t>
-            </a:r>
-            <a:endParaRPr lang="en-US" sz="1300" dirty="0"/>
-          </a:p>
-          <a:p>
-            <a:pPr indent="0" marL="0">
+              <a:t>[Medida para mejorar o consolidar el resultado]</a:t>
+            </a:r>
+            <a:endParaRPr lang="es-ES" sz="1200" dirty="0"/>
+          </a:p>
+          <a:p>
+            <a:pPr marL="0" indent="0">
               <a:spcBef>
-                <a:spcPts val="400"/>
+                <a:spcPts val="500"/>
               </a:spcBef>
               <a:buNone/>
             </a:pPr>
             <a:r>
-              <a:rPr lang="es-ES" sz="1200" b="1" dirty="0">
+              <a:rPr lang="es-ES" sz="1100" b="1" dirty="0">
                 <a:solidFill>
                   <a:schemeClr val="bg1"/>
                 </a:solidFill>
@@ -6027,14 +6012,14 @@
               <a:t>Campaña: </a:t>
             </a:r>
             <a:r>
-              <a:rPr lang="es-ES" sz="1200" dirty="0">
+              <a:rPr lang="es-ES" sz="1100" b="0" dirty="0">
                 <a:solidFill>
                   <a:schemeClr val="bg1"/>
                 </a:solidFill>
               </a:rPr>
-              <a:t>control de EPI al fichar y auditoría semanal.</a:t>
-            </a:r>
-            <a:endParaRPr lang="es-ES" sz="1200" dirty="0"/>
+              <a:t>Verificación del EPI en el control de acceso y auditoría semanal de cumplimiento.</a:t>
+            </a:r>
+            <a:endParaRPr lang="es-ES" sz="1100" dirty="0"/>
           </a:p>
         </p:txBody>
       </p:sp>
@@ -6284,8 +6269,8 @@
         </p:nvSpPr>
         <p:spPr>
           <a:xfrm>
-            <a:off x="5440680" y="1490472"/>
-            <a:ext cx="3017520" cy="548640"/>
+            <a:off x="5440680" y="1481328"/>
+            <a:ext cx="3017520" cy="457200"/>
           </a:xfrm>
           <a:prstGeom prst="rect">
             <a:avLst/>
@@ -6301,7 +6286,7 @@
               <a:buNone/>
             </a:pPr>
             <a:r>
-              <a:rPr lang="en-US" sz="3600" b="1" dirty="0">
+              <a:rPr lang="en-US" sz="3200" b="1" dirty="0">
                 <a:solidFill>
                   <a:schemeClr val="accent1"/>
                 </a:solidFill>
@@ -6320,8 +6305,8 @@
         </p:nvSpPr>
         <p:spPr>
           <a:xfrm>
-            <a:off x="5440680" y="2057400"/>
-            <a:ext cx="3017520" cy="274320"/>
+            <a:off x="5440680" y="1965960"/>
+            <a:ext cx="3017520" cy="256032"/>
           </a:xfrm>
           <a:prstGeom prst="rect">
             <a:avLst/>
@@ -6333,51 +6318,42 @@
           <a:bodyPr wrap="square" lIns="0" tIns="0" rIns="0" bIns="0" rtlCol="0" anchor="ctr"/>
           <a:lstStyle/>
           <a:p>
-            <a:pPr indent="0" marL="0">
-              <a:buNone/>
-            </a:pPr>
-            <a:r>
-              <a:rPr lang="en-US" sz="1200" b="1" dirty="0">
+            <a:pPr marL="0" indent="0">
+              <a:buNone/>
+            </a:pPr>
+            <a:r>
+              <a:rPr lang="es-ES" sz="1200" b="1" dirty="0">
                 <a:solidFill>
                   <a:schemeClr val="tx1"/>
                 </a:solidFill>
               </a:rPr>
               <a:t>Meta: </a:t>
             </a:r>
-            <a:pPr indent="0" marL="0">
-              <a:buNone/>
-            </a:pPr>
-            <a:r>
-              <a:rPr lang="en-US" sz="1200" dirty="0">
+            <a:r>
+              <a:rPr lang="es-ES" sz="1200" b="0" dirty="0">
                 <a:solidFill>
                   <a:schemeClr val="tx1"/>
                 </a:solidFill>
               </a:rPr>
-              <a:t>[00%]     </a:t>
-            </a:r>
-            <a:pPr indent="0" marL="0">
-              <a:buNone/>
-            </a:pPr>
-            <a:r>
-              <a:rPr lang="en-US" sz="1200" b="1" dirty="0">
+              <a:t>[00%]</a:t>
+            </a:r>
+            <a:r>
+              <a:rPr lang="es-ES" sz="1200" b="1" dirty="0">
                 <a:solidFill>
                   <a:schemeClr val="tx1"/>
                 </a:solidFill>
               </a:rPr>
-              <a:t>Variación: </a:t>
-            </a:r>
-            <a:pPr indent="0" marL="0">
-              <a:buNone/>
-            </a:pPr>
-            <a:r>
-              <a:rPr lang="en-US" sz="1200" dirty="0">
+              <a:t>     Variación: </a:t>
+            </a:r>
+            <a:r>
+              <a:rPr lang="es-ES" sz="1200" b="0" dirty="0">
                 <a:solidFill>
                   <a:schemeClr val="tx1"/>
                 </a:solidFill>
               </a:rPr>
-              <a:t>[±0 pts]</a:t>
-            </a:r>
-            <a:endParaRPr lang="en-US" sz="1200" dirty="0"/>
+              <a:t>[±0 p.p.]</a:t>
+            </a:r>
+            <a:endParaRPr lang="es-ES" sz="1200" dirty="0"/>
           </a:p>
         </p:txBody>
       </p:sp>
@@ -6389,8 +6365,8 @@
         </p:nvSpPr>
         <p:spPr>
           <a:xfrm>
-            <a:off x="5440680" y="2354580"/>
-            <a:ext cx="3017520" cy="205740"/>
+            <a:off x="5440680" y="2240280"/>
+            <a:ext cx="3017520" cy="256032"/>
           </a:xfrm>
           <a:prstGeom prst="rect">
             <a:avLst/>
@@ -6401,26 +6377,26 @@
           <a:bodyPr wrap="square" lIns="0" tIns="0" rIns="0" bIns="0" rtlCol="0" anchor="ctr"/>
           <a:lstStyle/>
           <a:p>
-            <a:pPr indent="0" marL="0">
-              <a:buNone/>
-            </a:pPr>
-            <a:r>
-              <a:rPr lang="es-ES" sz="1200" b="1" dirty="0">
+            <a:pPr marL="0" indent="0">
+              <a:buNone/>
+            </a:pPr>
+            <a:r>
+              <a:rPr lang="es-ES" sz="1100" b="1" dirty="0">
                 <a:solidFill>
                   <a:schemeClr val="tx1"/>
                 </a:solidFill>
               </a:rPr>
-              <a:t>Campaña: </a:t>
-            </a:r>
-            <a:r>
-              <a:rPr lang="es-ES" sz="1200" b="1" dirty="0">
+              <a:t>Campaña asociada: </a:t>
+            </a:r>
+            <a:r>
+              <a:rPr lang="es-ES" sz="1100" b="1" dirty="0">
                 <a:solidFill>
                   <a:schemeClr val="accent1"/>
                 </a:solidFill>
               </a:rPr>
               <a:t>«Carretilla segura»</a:t>
             </a:r>
-            <a:endParaRPr lang="es-ES" sz="1200" dirty="0"/>
+            <a:endParaRPr lang="es-ES" sz="1100" dirty="0"/>
           </a:p>
         </p:txBody>
       </p:sp>
@@ -6548,8 +6524,8 @@
         </p:nvSpPr>
         <p:spPr>
           <a:xfrm>
-            <a:off x="5394960" y="3630168"/>
-            <a:ext cx="3108960" cy="877824"/>
+            <a:off x="5394960" y="3639312"/>
+            <a:ext cx="3108960" cy="859536"/>
           </a:xfrm>
           <a:prstGeom prst="rect">
             <a:avLst/>
@@ -6561,39 +6537,36 @@
           <a:bodyPr wrap="square" lIns="0" tIns="0" rIns="0" bIns="0" rtlCol="0" anchor="ctr"/>
           <a:lstStyle/>
           <a:p>
-            <a:pPr indent="0" marL="0">
-              <a:buNone/>
-            </a:pPr>
-            <a:r>
-              <a:rPr lang="en-US" sz="1300" b="1" dirty="0">
+            <a:pPr marL="0" indent="0">
+              <a:buNone/>
+            </a:pPr>
+            <a:r>
+              <a:rPr lang="es-ES" sz="1200" b="1" dirty="0">
                 <a:solidFill>
                   <a:schemeClr val="bg1"/>
                 </a:solidFill>
               </a:rPr>
-              <a:t>Acción: </a:t>
-            </a:r>
-            <a:pPr indent="0" marL="0">
-              <a:buNone/>
-            </a:pPr>
-            <a:r>
-              <a:rPr lang="en-US" sz="1300" dirty="0">
+              <a:t>Plan de acción: </a:t>
+            </a:r>
+            <a:r>
+              <a:rPr lang="es-ES" sz="1200" b="0" dirty="0">
                 <a:solidFill>
                   <a:schemeClr val="bg1"/>
                 </a:solidFill>
               </a:rPr>
-              <a:t>[Qué haremos para mejorar o mantener el resultado]</a:t>
-            </a:r>
-            <a:endParaRPr lang="en-US" sz="1300" dirty="0"/>
-          </a:p>
-          <a:p>
-            <a:pPr indent="0" marL="0">
+              <a:t>[Medida para mejorar o consolidar el resultado]</a:t>
+            </a:r>
+            <a:endParaRPr lang="es-ES" sz="1200" dirty="0"/>
+          </a:p>
+          <a:p>
+            <a:pPr marL="0" indent="0">
               <a:spcBef>
-                <a:spcPts val="400"/>
+                <a:spcPts val="500"/>
               </a:spcBef>
               <a:buNone/>
             </a:pPr>
             <a:r>
-              <a:rPr lang="es-ES" sz="1200" b="1" dirty="0">
+              <a:rPr lang="es-ES" sz="1100" b="1" dirty="0">
                 <a:solidFill>
                   <a:schemeClr val="bg1"/>
                 </a:solidFill>
@@ -6601,14 +6574,14 @@
               <a:t>Campaña: </a:t>
             </a:r>
             <a:r>
-              <a:rPr lang="es-ES" sz="1200" dirty="0">
+              <a:rPr lang="es-ES" sz="1100" b="0" dirty="0">
                 <a:solidFill>
                   <a:schemeClr val="bg1"/>
                 </a:solidFill>
               </a:rPr>
-              <a:t>pasillo balizado y claxon en cada cruce.</a:t>
-            </a:r>
-            <a:endParaRPr lang="es-ES" sz="1200" dirty="0"/>
+              <a:t>Balizado de las vías de circulación y aviso acústico en los cruces.</a:t>
+            </a:r>
+            <a:endParaRPr lang="es-ES" sz="1100" dirty="0"/>
           </a:p>
         </p:txBody>
       </p:sp>
@@ -6858,8 +6831,8 @@
         </p:nvSpPr>
         <p:spPr>
           <a:xfrm>
-            <a:off x="5440680" y="1490472"/>
-            <a:ext cx="3017520" cy="548640"/>
+            <a:off x="5440680" y="1481328"/>
+            <a:ext cx="3017520" cy="457200"/>
           </a:xfrm>
           <a:prstGeom prst="rect">
             <a:avLst/>
@@ -6875,7 +6848,7 @@
               <a:buNone/>
             </a:pPr>
             <a:r>
-              <a:rPr lang="en-US" sz="3600" b="1" dirty="0">
+              <a:rPr lang="en-US" sz="3200" b="1" dirty="0">
                 <a:solidFill>
                   <a:schemeClr val="accent1"/>
                 </a:solidFill>
@@ -6894,8 +6867,8 @@
         </p:nvSpPr>
         <p:spPr>
           <a:xfrm>
-            <a:off x="5440680" y="2057400"/>
-            <a:ext cx="3017520" cy="274320"/>
+            <a:off x="5440680" y="1965960"/>
+            <a:ext cx="3017520" cy="256032"/>
           </a:xfrm>
           <a:prstGeom prst="rect">
             <a:avLst/>
@@ -6907,51 +6880,42 @@
           <a:bodyPr wrap="square" lIns="0" tIns="0" rIns="0" bIns="0" rtlCol="0" anchor="ctr"/>
           <a:lstStyle/>
           <a:p>
-            <a:pPr indent="0" marL="0">
-              <a:buNone/>
-            </a:pPr>
-            <a:r>
-              <a:rPr lang="en-US" sz="1200" b="1" dirty="0">
+            <a:pPr marL="0" indent="0">
+              <a:buNone/>
+            </a:pPr>
+            <a:r>
+              <a:rPr lang="es-ES" sz="1200" b="1" dirty="0">
                 <a:solidFill>
                   <a:schemeClr val="tx1"/>
                 </a:solidFill>
               </a:rPr>
               <a:t>Meta: </a:t>
             </a:r>
-            <a:pPr indent="0" marL="0">
-              <a:buNone/>
-            </a:pPr>
-            <a:r>
-              <a:rPr lang="en-US" sz="1200" dirty="0">
+            <a:r>
+              <a:rPr lang="es-ES" sz="1200" b="0" dirty="0">
                 <a:solidFill>
                   <a:schemeClr val="tx1"/>
                 </a:solidFill>
               </a:rPr>
-              <a:t>[00%]     </a:t>
-            </a:r>
-            <a:pPr indent="0" marL="0">
-              <a:buNone/>
-            </a:pPr>
-            <a:r>
-              <a:rPr lang="en-US" sz="1200" b="1" dirty="0">
+              <a:t>[00%]</a:t>
+            </a:r>
+            <a:r>
+              <a:rPr lang="es-ES" sz="1200" b="1" dirty="0">
                 <a:solidFill>
                   <a:schemeClr val="tx1"/>
                 </a:solidFill>
               </a:rPr>
-              <a:t>Variación: </a:t>
-            </a:r>
-            <a:pPr indent="0" marL="0">
-              <a:buNone/>
-            </a:pPr>
-            <a:r>
-              <a:rPr lang="en-US" sz="1200" dirty="0">
+              <a:t>     Variación: </a:t>
+            </a:r>
+            <a:r>
+              <a:rPr lang="es-ES" sz="1200" b="0" dirty="0">
                 <a:solidFill>
                   <a:schemeClr val="tx1"/>
                 </a:solidFill>
               </a:rPr>
-              <a:t>[±0 pts]</a:t>
-            </a:r>
-            <a:endParaRPr lang="en-US" sz="1200" dirty="0"/>
+              <a:t>[±0 p.p.]</a:t>
+            </a:r>
+            <a:endParaRPr lang="es-ES" sz="1200" dirty="0"/>
           </a:p>
         </p:txBody>
       </p:sp>
@@ -6963,8 +6927,8 @@
         </p:nvSpPr>
         <p:spPr>
           <a:xfrm>
-            <a:off x="5440680" y="2354580"/>
-            <a:ext cx="3017520" cy="205740"/>
+            <a:off x="5440680" y="2240280"/>
+            <a:ext cx="3017520" cy="256032"/>
           </a:xfrm>
           <a:prstGeom prst="rect">
             <a:avLst/>
@@ -6975,26 +6939,26 @@
           <a:bodyPr wrap="square" lIns="0" tIns="0" rIns="0" bIns="0" rtlCol="0" anchor="ctr"/>
           <a:lstStyle/>
           <a:p>
-            <a:pPr indent="0" marL="0">
-              <a:buNone/>
-            </a:pPr>
-            <a:r>
-              <a:rPr lang="es-ES" sz="1200" b="1" dirty="0">
+            <a:pPr marL="0" indent="0">
+              <a:buNone/>
+            </a:pPr>
+            <a:r>
+              <a:rPr lang="es-ES" sz="1100" b="1" dirty="0">
                 <a:solidFill>
                   <a:schemeClr val="tx1"/>
                 </a:solidFill>
               </a:rPr>
-              <a:t>Campaña: </a:t>
-            </a:r>
-            <a:r>
-              <a:rPr lang="es-ES" sz="1200" b="1" dirty="0">
+              <a:t>Campaña asociada: </a:t>
+            </a:r>
+            <a:r>
+              <a:rPr lang="es-ES" sz="1100" b="1" dirty="0">
                 <a:solidFill>
                   <a:schemeClr val="accent1"/>
                 </a:solidFill>
               </a:rPr>
               <a:t>«Altura sin riesgo»</a:t>
             </a:r>
-            <a:endParaRPr lang="es-ES" sz="1200" dirty="0"/>
+            <a:endParaRPr lang="es-ES" sz="1100" dirty="0"/>
           </a:p>
         </p:txBody>
       </p:sp>
@@ -7122,8 +7086,8 @@
         </p:nvSpPr>
         <p:spPr>
           <a:xfrm>
-            <a:off x="5394960" y="3630168"/>
-            <a:ext cx="3108960" cy="877824"/>
+            <a:off x="5394960" y="3639312"/>
+            <a:ext cx="3108960" cy="859536"/>
           </a:xfrm>
           <a:prstGeom prst="rect">
             <a:avLst/>
@@ -7135,39 +7099,36 @@
           <a:bodyPr wrap="square" lIns="0" tIns="0" rIns="0" bIns="0" rtlCol="0" anchor="ctr"/>
           <a:lstStyle/>
           <a:p>
-            <a:pPr indent="0" marL="0">
-              <a:buNone/>
-            </a:pPr>
-            <a:r>
-              <a:rPr lang="en-US" sz="1300" b="1" dirty="0">
+            <a:pPr marL="0" indent="0">
+              <a:buNone/>
+            </a:pPr>
+            <a:r>
+              <a:rPr lang="es-ES" sz="1200" b="1" dirty="0">
                 <a:solidFill>
                   <a:schemeClr val="bg1"/>
                 </a:solidFill>
               </a:rPr>
-              <a:t>Acción: </a:t>
-            </a:r>
-            <a:pPr indent="0" marL="0">
-              <a:buNone/>
-            </a:pPr>
-            <a:r>
-              <a:rPr lang="en-US" sz="1300" dirty="0">
+              <a:t>Plan de acción: </a:t>
+            </a:r>
+            <a:r>
+              <a:rPr lang="es-ES" sz="1200" b="0" dirty="0">
                 <a:solidFill>
                   <a:schemeClr val="bg1"/>
                 </a:solidFill>
               </a:rPr>
-              <a:t>[Qué haremos para mejorar o mantener el resultado]</a:t>
-            </a:r>
-            <a:endParaRPr lang="en-US" sz="1300" dirty="0"/>
-          </a:p>
-          <a:p>
-            <a:pPr indent="0" marL="0">
+              <a:t>[Medida para mejorar o consolidar el resultado]</a:t>
+            </a:r>
+            <a:endParaRPr lang="es-ES" sz="1200" dirty="0"/>
+          </a:p>
+          <a:p>
+            <a:pPr marL="0" indent="0">
               <a:spcBef>
-                <a:spcPts val="400"/>
+                <a:spcPts val="500"/>
               </a:spcBef>
               <a:buNone/>
             </a:pPr>
             <a:r>
-              <a:rPr lang="es-ES" sz="1200" b="1" dirty="0">
+              <a:rPr lang="es-ES" sz="1100" b="1" dirty="0">
                 <a:solidFill>
                   <a:schemeClr val="bg1"/>
                 </a:solidFill>
@@ -7175,14 +7136,14 @@
               <a:t>Campaña: </a:t>
             </a:r>
             <a:r>
-              <a:rPr lang="es-ES" sz="1200" dirty="0">
+              <a:rPr lang="es-ES" sz="1100" b="0" dirty="0">
                 <a:solidFill>
                   <a:schemeClr val="bg1"/>
                 </a:solidFill>
               </a:rPr>
-              <a:t>reposición en altura solo con plataforma homologada.</a:t>
-            </a:r>
-            <a:endParaRPr lang="es-ES" sz="1200" dirty="0"/>
+              <a:t>Reposición en altura solo con plataformas elevadoras homologadas.</a:t>
+            </a:r>
+            <a:endParaRPr lang="es-ES" sz="1100" dirty="0"/>
           </a:p>
         </p:txBody>
       </p:sp>
@@ -7432,8 +7393,8 @@
         </p:nvSpPr>
         <p:spPr>
           <a:xfrm>
-            <a:off x="5440680" y="1490472"/>
-            <a:ext cx="3017520" cy="548640"/>
+            <a:off x="5440680" y="1481328"/>
+            <a:ext cx="3017520" cy="457200"/>
           </a:xfrm>
           <a:prstGeom prst="rect">
             <a:avLst/>
@@ -7449,7 +7410,7 @@
               <a:buNone/>
             </a:pPr>
             <a:r>
-              <a:rPr lang="en-US" sz="3600" b="1" dirty="0">
+              <a:rPr lang="en-US" sz="3200" b="1" dirty="0">
                 <a:solidFill>
                   <a:schemeClr val="accent1"/>
                 </a:solidFill>
@@ -7468,8 +7429,8 @@
         </p:nvSpPr>
         <p:spPr>
           <a:xfrm>
-            <a:off x="5440680" y="2057400"/>
-            <a:ext cx="3017520" cy="274320"/>
+            <a:off x="5440680" y="1965960"/>
+            <a:ext cx="3017520" cy="256032"/>
           </a:xfrm>
           <a:prstGeom prst="rect">
             <a:avLst/>
@@ -7481,51 +7442,42 @@
           <a:bodyPr wrap="square" lIns="0" tIns="0" rIns="0" bIns="0" rtlCol="0" anchor="ctr"/>
           <a:lstStyle/>
           <a:p>
-            <a:pPr indent="0" marL="0">
-              <a:buNone/>
-            </a:pPr>
-            <a:r>
-              <a:rPr lang="en-US" sz="1200" b="1" dirty="0">
+            <a:pPr marL="0" indent="0">
+              <a:buNone/>
+            </a:pPr>
+            <a:r>
+              <a:rPr lang="es-ES" sz="1200" b="1" dirty="0">
                 <a:solidFill>
                   <a:schemeClr val="tx1"/>
                 </a:solidFill>
               </a:rPr>
               <a:t>Meta: </a:t>
             </a:r>
-            <a:pPr indent="0" marL="0">
-              <a:buNone/>
-            </a:pPr>
-            <a:r>
-              <a:rPr lang="en-US" sz="1200" dirty="0">
+            <a:r>
+              <a:rPr lang="es-ES" sz="1200" b="0" dirty="0">
                 <a:solidFill>
                   <a:schemeClr val="tx1"/>
                 </a:solidFill>
               </a:rPr>
-              <a:t>[00%]     </a:t>
-            </a:r>
-            <a:pPr indent="0" marL="0">
-              <a:buNone/>
-            </a:pPr>
-            <a:r>
-              <a:rPr lang="en-US" sz="1200" b="1" dirty="0">
+              <a:t>[00%]</a:t>
+            </a:r>
+            <a:r>
+              <a:rPr lang="es-ES" sz="1200" b="1" dirty="0">
                 <a:solidFill>
                   <a:schemeClr val="tx1"/>
                 </a:solidFill>
               </a:rPr>
-              <a:t>Variación: </a:t>
-            </a:r>
-            <a:pPr indent="0" marL="0">
-              <a:buNone/>
-            </a:pPr>
-            <a:r>
-              <a:rPr lang="en-US" sz="1200" dirty="0">
+              <a:t>     Variación: </a:t>
+            </a:r>
+            <a:r>
+              <a:rPr lang="es-ES" sz="1200" b="0" dirty="0">
                 <a:solidFill>
                   <a:schemeClr val="tx1"/>
                 </a:solidFill>
               </a:rPr>
-              <a:t>[±0 pts]</a:t>
-            </a:r>
-            <a:endParaRPr lang="en-US" sz="1200" dirty="0"/>
+              <a:t>[±0 p.p.]</a:t>
+            </a:r>
+            <a:endParaRPr lang="es-ES" sz="1200" dirty="0"/>
           </a:p>
         </p:txBody>
       </p:sp>
@@ -7537,8 +7489,8 @@
         </p:nvSpPr>
         <p:spPr>
           <a:xfrm>
-            <a:off x="5440680" y="2354580"/>
-            <a:ext cx="3017520" cy="205740"/>
+            <a:off x="5440680" y="2240280"/>
+            <a:ext cx="3017520" cy="256032"/>
           </a:xfrm>
           <a:prstGeom prst="rect">
             <a:avLst/>
@@ -7549,26 +7501,26 @@
           <a:bodyPr wrap="square" lIns="0" tIns="0" rIns="0" bIns="0" rtlCol="0" anchor="ctr"/>
           <a:lstStyle/>
           <a:p>
-            <a:pPr indent="0" marL="0">
-              <a:buNone/>
-            </a:pPr>
-            <a:r>
-              <a:rPr lang="es-ES" sz="1200" b="1" dirty="0">
+            <a:pPr marL="0" indent="0">
+              <a:buNone/>
+            </a:pPr>
+            <a:r>
+              <a:rPr lang="es-ES" sz="1100" b="1" dirty="0">
                 <a:solidFill>
                   <a:schemeClr val="tx1"/>
                 </a:solidFill>
               </a:rPr>
-              <a:t>Campaña: </a:t>
-            </a:r>
-            <a:r>
-              <a:rPr lang="es-ES" sz="1200" b="1" dirty="0">
+              <a:t>Campaña asociada: </a:t>
+            </a:r>
+            <a:r>
+              <a:rPr lang="es-ES" sz="1100" b="1" dirty="0">
                 <a:solidFill>
                   <a:schemeClr val="accent1"/>
                 </a:solidFill>
               </a:rPr>
               <a:t>«Pasillos despejados»</a:t>
             </a:r>
-            <a:endParaRPr lang="es-ES" sz="1200" dirty="0"/>
+            <a:endParaRPr lang="es-ES" sz="1100" dirty="0"/>
           </a:p>
         </p:txBody>
       </p:sp>
@@ -7696,8 +7648,8 @@
         </p:nvSpPr>
         <p:spPr>
           <a:xfrm>
-            <a:off x="5394960" y="3630168"/>
-            <a:ext cx="3108960" cy="877824"/>
+            <a:off x="5394960" y="3639312"/>
+            <a:ext cx="3108960" cy="859536"/>
           </a:xfrm>
           <a:prstGeom prst="rect">
             <a:avLst/>
@@ -7709,39 +7661,36 @@
           <a:bodyPr wrap="square" lIns="0" tIns="0" rIns="0" bIns="0" rtlCol="0" anchor="ctr"/>
           <a:lstStyle/>
           <a:p>
-            <a:pPr indent="0" marL="0">
-              <a:buNone/>
-            </a:pPr>
-            <a:r>
-              <a:rPr lang="en-US" sz="1300" b="1" dirty="0">
+            <a:pPr marL="0" indent="0">
+              <a:buNone/>
+            </a:pPr>
+            <a:r>
+              <a:rPr lang="es-ES" sz="1200" b="1" dirty="0">
                 <a:solidFill>
                   <a:schemeClr val="bg1"/>
                 </a:solidFill>
               </a:rPr>
-              <a:t>Acción: </a:t>
-            </a:r>
-            <a:pPr indent="0" marL="0">
-              <a:buNone/>
-            </a:pPr>
-            <a:r>
-              <a:rPr lang="en-US" sz="1300" dirty="0">
+              <a:t>Plan de acción: </a:t>
+            </a:r>
+            <a:r>
+              <a:rPr lang="es-ES" sz="1200" b="0" dirty="0">
                 <a:solidFill>
                   <a:schemeClr val="bg1"/>
                 </a:solidFill>
               </a:rPr>
-              <a:t>[Qué haremos para mejorar o mantener el resultado]</a:t>
-            </a:r>
-            <a:endParaRPr lang="en-US" sz="1300" dirty="0"/>
-          </a:p>
-          <a:p>
-            <a:pPr indent="0" marL="0">
+              <a:t>[Medida para mejorar o consolidar el resultado]</a:t>
+            </a:r>
+            <a:endParaRPr lang="es-ES" sz="1200" dirty="0"/>
+          </a:p>
+          <a:p>
+            <a:pPr marL="0" indent="0">
               <a:spcBef>
-                <a:spcPts val="400"/>
+                <a:spcPts val="500"/>
               </a:spcBef>
               <a:buNone/>
             </a:pPr>
             <a:r>
-              <a:rPr lang="es-ES" sz="1200" b="1" dirty="0">
+              <a:rPr lang="es-ES" sz="1100" b="1" dirty="0">
                 <a:solidFill>
                   <a:schemeClr val="bg1"/>
                 </a:solidFill>
@@ -7749,14 +7698,14 @@
               <a:t>Campaña: </a:t>
             </a:r>
             <a:r>
-              <a:rPr lang="es-ES" sz="1200" dirty="0">
+              <a:rPr lang="es-ES" sz="1100" b="0" dirty="0">
                 <a:solidFill>
                   <a:schemeClr val="bg1"/>
                 </a:solidFill>
               </a:rPr>
-              <a:t>ronda de orden y limpieza en cada turno.</a:t>
-            </a:r>
-            <a:endParaRPr lang="es-ES" sz="1200" dirty="0"/>
+              <a:t>Inspección de orden y limpieza al inicio de cada turno.</a:t>
+            </a:r>
+            <a:endParaRPr lang="es-ES" sz="1100" dirty="0"/>
           </a:p>
         </p:txBody>
       </p:sp>
@@ -8665,6 +8614,17 @@
               </a:rPr>
               <a:t>Responsable: </a:t>
             </a:r>
+            <a:r>
+              <a:rPr lang="en-US" sz="1300" dirty="0">
+                <a:solidFill>
+                  <a:schemeClr val="tx1"/>
+                </a:solidFill>
+              </a:rPr>
+              <a:t>[Nombre]</a:t>
+            </a:r>
+            <a:endParaRPr lang="en-US" sz="1300" dirty="0"/>
+          </a:p>
+          <a:p>
             <a:pPr indent="0" marL="0">
               <a:spcAft>
                 <a:spcPts val="400"/>
@@ -8672,12 +8632,20 @@
               <a:buNone/>
             </a:pPr>
             <a:r>
+              <a:rPr lang="en-US" sz="1300" b="1" dirty="0">
+                <a:solidFill>
+                  <a:schemeClr val="tx1"/>
+                </a:solidFill>
+              </a:rPr>
+              <a:t>Fecha límite: </a:t>
+            </a:r>
+            <a:r>
               <a:rPr lang="en-US" sz="1300" dirty="0">
                 <a:solidFill>
                   <a:schemeClr val="tx1"/>
                 </a:solidFill>
               </a:rPr>
-              <a:t>[Nombre]</a:t>
+              <a:t>[dd/mm/aaaa]</a:t>
             </a:r>
             <a:endParaRPr lang="en-US" sz="1300" dirty="0"/>
           </a:p>
@@ -8694,45 +8662,8 @@
                   <a:schemeClr val="tx1"/>
                 </a:solidFill>
               </a:rPr>
-              <a:t>Fecha límite: </a:t>
-            </a:r>
-            <a:pPr indent="0" marL="0">
-              <a:spcAft>
-                <a:spcPts val="400"/>
-              </a:spcAft>
-              <a:buNone/>
-            </a:pPr>
-            <a:r>
-              <a:rPr lang="en-US" sz="1300" dirty="0">
-                <a:solidFill>
-                  <a:schemeClr val="tx1"/>
-                </a:solidFill>
-              </a:rPr>
-              <a:t>[dd/mm/aaaa]</a:t>
-            </a:r>
-            <a:endParaRPr lang="en-US" sz="1300" dirty="0"/>
-          </a:p>
-          <a:p>
-            <a:pPr indent="0" marL="0">
-              <a:spcAft>
-                <a:spcPts val="400"/>
-              </a:spcAft>
-              <a:buNone/>
-            </a:pPr>
-            <a:r>
-              <a:rPr lang="en-US" sz="1300" b="1" dirty="0">
-                <a:solidFill>
-                  <a:schemeClr val="tx1"/>
-                </a:solidFill>
-              </a:rPr>
               <a:t>KPI impactado: </a:t>
             </a:r>
-            <a:pPr indent="0" marL="0">
-              <a:spcAft>
-                <a:spcPts val="400"/>
-              </a:spcAft>
-              <a:buNone/>
-            </a:pPr>
             <a:r>
               <a:rPr lang="en-US" sz="1300" dirty="0">
                 <a:solidFill>
@@ -9001,6 +8932,17 @@
               </a:rPr>
               <a:t>Responsable: </a:t>
             </a:r>
+            <a:r>
+              <a:rPr lang="en-US" sz="1300" dirty="0">
+                <a:solidFill>
+                  <a:schemeClr val="tx1"/>
+                </a:solidFill>
+              </a:rPr>
+              <a:t>[Nombre]</a:t>
+            </a:r>
+            <a:endParaRPr lang="en-US" sz="1300" dirty="0"/>
+          </a:p>
+          <a:p>
             <a:pPr indent="0" marL="0">
               <a:spcAft>
                 <a:spcPts val="400"/>
@@ -9008,12 +8950,20 @@
               <a:buNone/>
             </a:pPr>
             <a:r>
+              <a:rPr lang="en-US" sz="1300" b="1" dirty="0">
+                <a:solidFill>
+                  <a:schemeClr val="tx1"/>
+                </a:solidFill>
+              </a:rPr>
+              <a:t>Fecha límite: </a:t>
+            </a:r>
+            <a:r>
               <a:rPr lang="en-US" sz="1300" dirty="0">
                 <a:solidFill>
                   <a:schemeClr val="tx1"/>
                 </a:solidFill>
               </a:rPr>
-              <a:t>[Nombre]</a:t>
+              <a:t>[dd/mm/aaaa]</a:t>
             </a:r>
             <a:endParaRPr lang="en-US" sz="1300" dirty="0"/>
           </a:p>
@@ -9030,45 +8980,8 @@
                   <a:schemeClr val="tx1"/>
                 </a:solidFill>
               </a:rPr>
-              <a:t>Fecha límite: </a:t>
-            </a:r>
-            <a:pPr indent="0" marL="0">
-              <a:spcAft>
-                <a:spcPts val="400"/>
-              </a:spcAft>
-              <a:buNone/>
-            </a:pPr>
-            <a:r>
-              <a:rPr lang="en-US" sz="1300" dirty="0">
-                <a:solidFill>
-                  <a:schemeClr val="tx1"/>
-                </a:solidFill>
-              </a:rPr>
-              <a:t>[dd/mm/aaaa]</a:t>
-            </a:r>
-            <a:endParaRPr lang="en-US" sz="1300" dirty="0"/>
-          </a:p>
-          <a:p>
-            <a:pPr indent="0" marL="0">
-              <a:spcAft>
-                <a:spcPts val="400"/>
-              </a:spcAft>
-              <a:buNone/>
-            </a:pPr>
-            <a:r>
-              <a:rPr lang="en-US" sz="1300" b="1" dirty="0">
-                <a:solidFill>
-                  <a:schemeClr val="tx1"/>
-                </a:solidFill>
-              </a:rPr>
               <a:t>KPI impactado: </a:t>
             </a:r>
-            <a:pPr indent="0" marL="0">
-              <a:spcAft>
-                <a:spcPts val="400"/>
-              </a:spcAft>
-              <a:buNone/>
-            </a:pPr>
             <a:r>
               <a:rPr lang="en-US" sz="1300" dirty="0">
                 <a:solidFill>
@@ -9337,6 +9250,17 @@
               </a:rPr>
               <a:t>Responsable: </a:t>
             </a:r>
+            <a:r>
+              <a:rPr lang="en-US" sz="1300" dirty="0">
+                <a:solidFill>
+                  <a:schemeClr val="tx1"/>
+                </a:solidFill>
+              </a:rPr>
+              <a:t>[Nombre]</a:t>
+            </a:r>
+            <a:endParaRPr lang="en-US" sz="1300" dirty="0"/>
+          </a:p>
+          <a:p>
             <a:pPr indent="0" marL="0">
               <a:spcAft>
                 <a:spcPts val="400"/>
@@ -9344,12 +9268,20 @@
               <a:buNone/>
             </a:pPr>
             <a:r>
+              <a:rPr lang="en-US" sz="1300" b="1" dirty="0">
+                <a:solidFill>
+                  <a:schemeClr val="tx1"/>
+                </a:solidFill>
+              </a:rPr>
+              <a:t>Fecha límite: </a:t>
+            </a:r>
+            <a:r>
               <a:rPr lang="en-US" sz="1300" dirty="0">
                 <a:solidFill>
                   <a:schemeClr val="tx1"/>
                 </a:solidFill>
               </a:rPr>
-              <a:t>[Nombre]</a:t>
+              <a:t>[dd/mm/aaaa]</a:t>
             </a:r>
             <a:endParaRPr lang="en-US" sz="1300" dirty="0"/>
           </a:p>
@@ -9366,45 +9298,8 @@
                   <a:schemeClr val="tx1"/>
                 </a:solidFill>
               </a:rPr>
-              <a:t>Fecha límite: </a:t>
-            </a:r>
-            <a:pPr indent="0" marL="0">
-              <a:spcAft>
-                <a:spcPts val="400"/>
-              </a:spcAft>
-              <a:buNone/>
-            </a:pPr>
-            <a:r>
-              <a:rPr lang="en-US" sz="1300" dirty="0">
-                <a:solidFill>
-                  <a:schemeClr val="tx1"/>
-                </a:solidFill>
-              </a:rPr>
-              <a:t>[dd/mm/aaaa]</a:t>
-            </a:r>
-            <a:endParaRPr lang="en-US" sz="1300" dirty="0"/>
-          </a:p>
-          <a:p>
-            <a:pPr indent="0" marL="0">
-              <a:spcAft>
-                <a:spcPts val="400"/>
-              </a:spcAft>
-              <a:buNone/>
-            </a:pPr>
-            <a:r>
-              <a:rPr lang="en-US" sz="1300" b="1" dirty="0">
-                <a:solidFill>
-                  <a:schemeClr val="tx1"/>
-                </a:solidFill>
-              </a:rPr>
               <a:t>KPI impactado: </a:t>
             </a:r>
-            <a:pPr indent="0" marL="0">
-              <a:spcAft>
-                <a:spcPts val="400"/>
-              </a:spcAft>
-              <a:buNone/>
-            </a:pPr>
             <a:r>
               <a:rPr lang="en-US" sz="1300" dirty="0">
                 <a:solidFill>

</xml_diff>